<commit_message>
feat: explain the mechanism, map the competition and cut the tech slide
The science slide never said what FSRS is — it read as jargon. It now leads with the
forgetting curve and explains, in three lines, that the algorithm estimates how long a memory
lasts in that person and brings the card back just before the drop.

The competitive table became a quadrant: measures forgetting over time against returns it to
the teacher. The empty corner is the argument, and it survives a judge who knows the market
better than a six-row table does.

The script now opens every slide with what the slide is arguing, so the speaker carries the
reasoning instead of reciting loose numbers.
</commit_message>
<xml_diff>
--- a/docs/pitch/Memfeed-Pitch-Deck.pptx
+++ b/docs/pitch/Memfeed-Pitch-Deck.pptx
@@ -512,6 +512,12 @@
           <a:lstStyle/>
           <a:p>
             <a:r>
+              <a:t>O ponto deste slide: Abrir com a lacuna, não com o produto. O júri precisa sentir a pergunta sem resposta — *quanto sobrou daquela aula?* — antes de ver qualquer tela. Se ele sair do slide 1 com essa pergunta na cabeça, o resto do pitch é a resposta.</a:t>
+            </a:r>
+          </a:p>
+          <a:p/>
+          <a:p>
+            <a:r>
               <a:t>No slide: "Memfeed" grande. "A interface do TikTok, o algoritmo do Ebbinghaus." O parágrafo de abertura. Fundo escuro.</a:t>
             </a:r>
           </a:p>
@@ -624,6 +630,12 @@
           <a:lstStyle/>
           <a:p>
             <a:r>
+              <a:t>O ponto deste slide: Fechar mostrando que a conta fecha por causa da arquitetura, não apesar dela. A aula do professor é gerada uma vez e consumida por 34 alunos; a geração que o aluno pede é 1:1. Por isso a escola pública sai de graça sem quebrar o modelo. Termine no lema e segure o silêncio.</a:t>
+            </a:r>
+          </a:p>
+          <a:p/>
+          <a:p>
+            <a:r>
               <a:t>No slide: três portas + a unidade econômica + "O problema nunca foi o formato."</a:t>
             </a:r>
           </a:p>
@@ -1130,6 +1142,12 @@
           <a:lstStyle/>
           <a:p>
             <a:r>
+              <a:t>O ponto deste slide: Provar que a IA, do jeito que o aluno usa hoje, piora a memória. Os 83% não são um dado sobre tecnologia: são a evidência de que atalho cognitivo cobra juros. É o que justifica um produto que devolve esforço em vez de poupá-lo.</a:t>
+            </a:r>
+          </a:p>
+          <a:p/>
+          <a:p>
+            <a:r>
               <a:t>No slide: 83% gigante. Caixa escura à direita com 7 em 10 · 32% · 73%.</a:t>
             </a:r>
           </a:p>
@@ -1236,6 +1254,12 @@
           <a:lstStyle/>
           <a:p>
             <a:r>
+              <a:t>O ponto deste slide: Mostrar que as três falhas se alimentam: atenção curta, IA como atalho e estudo por releitura. E fechar apontando para o professor — ele é quem fica no escuro, e é a dor que o nosso painel resolve. Este slide monta a persona do slide seguinte.</a:t>
+            </a:r>
+          </a:p>
+          <a:p/>
+          <a:p>
+            <a:r>
               <a:t>No slide: 01 / 02 / 03 em três colunas. Faixa escura embaixo: "E o professor está no escuro."</a:t>
             </a:r>
           </a:p>
@@ -1348,6 +1372,12 @@
           <a:lstStyle/>
           <a:p>
             <a:r>
+              <a:t>O ponto deste slide: Ancorar na Lei 15.100. O celular está proibido na escola exceto para fim pedagógico sob orientação do professor — e como quem publica o conteúdo é o professor, usar o Memfeed é essa exceção, não uma brecha nela. Esse é o argumento que abre porta de escola pública.</a:t>
+            </a:r>
+          </a:p>
+          <a:p/>
+          <a:p>
+            <a:r>
               <a:t>No slide: Júlia e Prof. Marcos. Rodapé com a Lei 15.100 e os 92%.</a:t>
             </a:r>
           </a:p>
@@ -1466,6 +1496,12 @@
           <a:lstStyle/>
           <a:p>
             <a:r>
+              <a:t>O ponto deste slide: Explicar a arquitetura do produto em uma imagem: duas origens, uma fila. O ponto que não pode escapar é que as duas caem no mesmo FSRS — é isso que faz ser um produto só, e não um quiz do professor colado num app de estudo.</a:t>
+            </a:r>
+          </a:p>
+          <a:p/>
+          <a:p>
+            <a:r>
               <a:t>No slide: diagrama — duas caixas → "Mesma fila FSRS". À direita, as três mecânicas.</a:t>
             </a:r>
           </a:p>
@@ -1596,6 +1632,12 @@
           <a:lstStyle/>
           <a:p>
             <a:r>
+              <a:t>O ponto deste slide: O coração do pitch. Todo mundo sabe o acerto no dia da atividade. Ninguém devolve ao professor quanto sobrou uma semana depois. Fale o número devagar: 96% no dia, 77% em D+7. A queda de 19 pontos é o que dispara a ação — não é relatório para arquivar, é gatilho de intervenção.</a:t>
+            </a:r>
+          </a:p>
+          <a:p/>
+          <a:p>
+            <a:r>
               <a:t>No slide: painel do professor. Ciclo de Krebs, 96% no dia, 77% no D+7, −19 pontos. Estados firme/em risco/esquecido. A frase do Wayground na caixa escura.</a:t>
             </a:r>
           </a:p>
@@ -1720,43 +1762,55 @@
           <a:lstStyle/>
           <a:p>
             <a:r>
-              <a:t>No slide: tabela — estudo · achado · o que decide no produto.</a:t>
-            </a:r>
-          </a:p>
-          <a:p/>
-          <a:p>
-            <a:r>
-              <a:t>Nada disso é invenção nossa. Cada decisão tem um estudo atrás.</a:t>
-            </a:r>
-          </a:p>
-          <a:p/>
-          <a:p>
-            <a:r>
-              <a:t>Roediger e Karpicke definem que o card é pergunta, nunca releitura. Cepeda define que o espaçamento é o núcleo. Murre e Dros dizem quando o card precisa voltar.</a:t>
-            </a:r>
-          </a:p>
-          <a:p/>
-          <a:p>
-            <a:r>
-              <a:t>E seja honesto comigo sobre uma coisa: (pausa) o FSRS é aberto. É o algoritmo padrão do Anki desde 2023. Qualquer time aqui copia o motor numa semana.</a:t>
-            </a:r>
-          </a:p>
-          <a:p/>
-          <a:p>
-            <a:r>
-              <a:t>A gente usa o commodity de propósito. O motor nunca foi o diferencial — e dizer o contrário não sobreviveria à primeira pergunta de vocês.</a:t>
-            </a:r>
-          </a:p>
-          <a:p/>
-          <a:p>
-            <a:r>
-              <a:t>`→ avança o slide`</a:t>
-            </a:r>
-          </a:p>
-          <a:p/>
-          <a:p>
-            <a:r>
-              <a:t>---</a:t>
+              <a:t>O ponto deste slide: Aqui o júri precisa entender o que é FSRS, senão o resto vira jargão. Explique como se fosse para a sua mãe: é um algoritmo que, a cada resposta, estima quanto tempo aquela memória dura em você, e traz o card de volta pouco antes de você esquecer. Mostre a curva. E seja honesto: o algoritmo é aberto e comum — o diferencial nunca foi o motor.</a:t>
+            </a:r>
+          </a:p>
+          <a:p/>
+          <a:p>
+            <a:r>
+              <a:t>No slide: à esquerda, a curva de esquecimento — pontilhada cinza sem revisão, verde com o card voltando nos dias 1, 3, 7 e 16. À direita, o que é o FSRS em três parágrafos. Embaixo, os três estudos.</a:t>
+            </a:r>
+          </a:p>
+          <a:p/>
+          <a:p>
+            <a:r>
+              <a:t>Fala: "Uma palavra que vocês vão ouvir de novo: FSRS. (pausa)</a:t>
+            </a:r>
+          </a:p>
+          <a:p/>
+          <a:p>
+            <a:r>
+              <a:t>Free Spaced Repetition Scheduler. É um algoritmo aberto — o mesmo que o Anki adotou como padrão desde 2023.</a:t>
+            </a:r>
+          </a:p>
+          <a:p/>
+          <a:p>
+            <a:r>
+              <a:t>O que ele faz, em uma frase: a cada resposta, ele estima quanto tempo aquela memória dura em você — e marca o card para voltar pouco antes da queda.</a:t>
+            </a:r>
+          </a:p>
+          <a:p/>
+          <a:p>
+            <a:r>
+              <a:t>Errou, volta em minutos. Acertou sem esforço, volta daqui a semanas. (pausa)</a:t>
+            </a:r>
+          </a:p>
+          <a:p/>
+          <a:p>
+            <a:r>
+              <a:t>Essa é a linha pontilhada: o que acontece sem revisão. E essa é a verde: o mesmo conteúdo, com o card voltando na hora certa.</a:t>
+            </a:r>
+          </a:p>
+          <a:p/>
+          <a:p>
+            <a:r>
+              <a:t>E eu quero ser honesto com vocês: o algoritmo é commodity. O motor nunca foi o nosso diferencial — o diferencial é o que a gente faz com o que ele mede."</a:t>
+            </a:r>
+          </a:p>
+          <a:p/>
+          <a:p>
+            <a:r>
+              <a:t>Aponte a curva pontilhada ao dizer "sem revisão" e a verde ao dizer "na hora certa". A frase sobre commodity é desarme preventivo: não deixe um jurado dizer isso antes de você. Deixa: "Então por que ninguém já fez?"</a:t>
             </a:r>
           </a:p>
         </p:txBody>
@@ -1826,43 +1880,55 @@
           <a:lstStyle/>
           <a:p>
             <a:r>
-              <a:t>No slide: tabela com Kahoot, Wayground, Seneca, Anki, Plurall e Memfeed.</a:t>
-            </a:r>
-          </a:p>
-          <a:p/>
-          <a:p>
-            <a:r>
-              <a:t>Então o que é o diferencial? Olha a tabela.</a:t>
-            </a:r>
-          </a:p>
-          <a:p/>
-          <a:p>
-            <a:r>
-              <a:t>Kahoot gera questão de um assunto, melhor que a gente. Mas a própria central de ajuda dele diz: estudo solo não gera relatório. E o post oficial de março instrui o professor a criar um novo kahoot e lembrar de rodar "uma ou duas semanas depois". Esse "lembrar" é trabalho manual.</a:t>
-            </a:r>
-          </a:p>
-          <a:p/>
-          <a:p>
-            <a:r>
-              <a:t>E o mais perigoso não é o Kahoot. É o Seneca. Ele já usa a curva de esquecimento de Ebbinghaus para agendar a revisão do aluno. (pausa) E mesmo assim, o painel do professor entrega conclusão de tarefa, nota e tempo de estudo. A curva morre no motor. Ela nunca vira relatório.</a:t>
-            </a:r>
-          </a:p>
-          <a:p/>
-          <a:p>
-            <a:r>
-              <a:t>É essa coluna que está vazia no mercado. Não o algoritmo — a tradução do algoritmo para quem deu a aula.</a:t>
-            </a:r>
-          </a:p>
-          <a:p/>
-          <a:p>
-            <a:r>
-              <a:t>`→ avança o slide`</a:t>
-            </a:r>
-          </a:p>
-          <a:p/>
-          <a:p>
-            <a:r>
-              <a:t>---</a:t>
+              <a:t>O ponto deste slide: Desarmar o jurado que conhece o mercado, admitindo antes dele. Todos são melhores que nós em alguma coisa. O que ninguém ocupa é o canto onde as duas coisas acontecem juntas: medir o esquecimento e devolver ao professor. Cite o Seneca de propósito — mostra que você pesquisou de verdade e que não está atacando o alvo fácil.</a:t>
+            </a:r>
+          </a:p>
+          <a:p/>
+          <a:p>
+            <a:r>
+              <a:t>No slide: quadrante. Eixo horizontal *mede o esquecimento no tempo*, vertical *devolve ao professor*. Seis produtos plotados; o canto superior direito destacado, com o Memfeed sozinho nele.</a:t>
+            </a:r>
+          </a:p>
+          <a:p/>
+          <a:p>
+            <a:r>
+              <a:t>Fala: "Esse é o mapa da concorrência, e ele tem dois eixos. (pausa)</a:t>
+            </a:r>
+          </a:p>
+          <a:p/>
+          <a:p>
+            <a:r>
+              <a:t>Horizontal: o produto mede o esquecimento ao longo do tempo? Vertical: ele devolve isso ao professor?</a:t>
+            </a:r>
+          </a:p>
+          <a:p/>
+          <a:p>
+            <a:r>
+              <a:t>O Kahoot e o Wayground estão aqui em cima à esquerda — têm relatório bom, mas do dia da atividade.</a:t>
+            </a:r>
+          </a:p>
+          <a:p/>
+          <a:p>
+            <a:r>
+              <a:t>O Anki e o Seneca estão à direita embaixo — medem esquecimento de verdade, e entregam só ao aluno.</a:t>
+            </a:r>
+          </a:p>
+          <a:p/>
+          <a:p>
+            <a:r>
+              <a:t>E o mais perigoso não é o Kahoot. É o Seneca, que já usa a curva de Ebbinghaus para agendar a revisão. Mesmo ele nunca devolve a curva ao professor — o painel dele mostra conclusão, nota e tempo de estudo. (pausa)</a:t>
+            </a:r>
+          </a:p>
+          <a:p/>
+          <a:p>
+            <a:r>
+              <a:t>O canto superior direito está vazio. É onde a gente está."</a:t>
+            </a:r>
+          </a:p>
+          <a:p/>
+          <a:p>
+            <a:r>
+              <a:t>Aponte fisicamente os quatro cantos enquanto fala. Citar o Seneca como o mais perigoso mostra pesquisa real e tira do jurado a chance de te pegar. Deixa: "E a tecnologia por trás disso não prende a gente a ninguém."</a:t>
             </a:r>
           </a:p>
         </p:txBody>
@@ -1932,37 +1998,43 @@
           <a:lstStyle/>
           <a:p>
             <a:r>
-              <a:t>No slide: três cartões — geração agnóstica de provedor · a Wikipédia · a stack. Faixa embaixo: no ar hoje × o que vem depois.</a:t>
-            </a:r>
-          </a:p>
-          <a:p/>
-          <a:p>
-            <a:r>
-              <a:t>Rápido sobre a técnica, porque tem uma decisão aqui que eu quero que fique.</a:t>
-            </a:r>
-          </a:p>
-          <a:p/>
-          <a:p>
-            <a:r>
-              <a:t>A geração é agnóstica de provedor. Uma interface, duas implementações — Anthropic e Gemini — escolhidas pela chave que está no ambiente. A saída passa por JSON schema antes de virar card. Hoje roda no tier gratuito do Gemini: o custo de inferência é substituível, não estrutural.</a:t>
-            </a:r>
-          </a:p>
-          <a:p/>
-          <a:p>
-            <a:r>
-              <a:t>E a figura de cada card vem do acervo da Wikipédia. Nunca de modelo de imagem. (pausa) Porque diagrama científico gerado por IA sai com a seta trocada — e num app de educação, isso ensina errado.</a:t>
-            </a:r>
-          </a:p>
-          <a:p/>
-          <a:p>
-            <a:r>
-              <a:t>`→ avança o slide`</a:t>
-            </a:r>
-          </a:p>
-          <a:p/>
-          <a:p>
-            <a:r>
-              <a:t>---</a:t>
+              <a:t>O ponto deste slide: Tirar o risco de fornecedor da mesa em vinte segundos. Trocar de LLM é variável de ambiente, não reescrita. E a decisão que vale repetir: a figura do card vem do acervo da Wikipédia, nunca de modelo de imagem — porque diagrama científico gerado por IA sai errado, e num app de educação erro se propaga pela fila de revisão.</a:t>
+            </a:r>
+          </a:p>
+          <a:p/>
+          <a:p>
+            <a:r>
+              <a:t>No slide: três cartões — modelo trocável, a figura vinda do acervo (destacado), e a stack.</a:t>
+            </a:r>
+          </a:p>
+          <a:p/>
+          <a:p>
+            <a:r>
+              <a:t>Fala: "Três coisas, rápido. (pausa)</a:t>
+            </a:r>
+          </a:p>
+          <a:p/>
+          <a:p>
+            <a:r>
+              <a:t>Um: trocar de modelo de IA aqui é mudar uma variável de ambiente. Duas implementações da mesma interface, e a saída passa por validação de schema antes de virar card. Hoje roda no tier gratuito do Gemini — o custo de inferência é substituível, não estrutural.</a:t>
+            </a:r>
+          </a:p>
+          <a:p/>
+          <a:p>
+            <a:r>
+              <a:t>Dois, e essa é a decisão que nos separa: a figura de cada card vem do acervo da Wikipédia. Nunca de modelo de imagem. Diagrama científico gerado por IA sai com a seta trocada e a molécula inventada. Num app de educação isso ensina errado — e o erro se propaga justamente pela fila de revisão, que é o que fixa memória.</a:t>
+            </a:r>
+          </a:p>
+          <a:p/>
+          <a:p>
+            <a:r>
+              <a:t>Três: a stack é aberta das duas pontas, com a mesma API servindo o aluno e o professor."</a:t>
+            </a:r>
+          </a:p>
+          <a:p/>
+          <a:p>
+            <a:r>
+              <a:t>O item dois é o que fica na cabeça do jurado — diga devagar. Deixa: "E como isso se sustenta?"</a:t>
             </a:r>
           </a:p>
         </p:txBody>

</xml_diff>

<commit_message>
feat: trade the vendor slide for live proof and a QR the jury can scan
Nobody asks about vendor lock-in in a five-minute pitch. The question a hackathon jury
actually asks is whether the thing exists, so slide 9 now shows the panel and the app running
against the real API, and a QR that opens the demo in the judge's own browser.

The one claim worth keeping from the old slide stayed: the illustration comes from the
archive, never from an image model.

The QR URL lives in a single constant — regenerate with "node gerar-qr.js" once the deploy
has its address.
</commit_message>
<xml_diff>
--- a/docs/pitch/Memfeed-Pitch-Deck.pptx
+++ b/docs/pitch/Memfeed-Pitch-Deck.pptx
@@ -1892,7 +1892,7 @@
           <a:p/>
           <a:p>
             <a:r>
-              <a:t>Fala: "Esse é o mapa da concorrência, e ele tem dois eixos. (pausa)</a:t>
+              <a:t>Fala: "Vou começar admitindo: todos eles são melhores que a gente em alguma coisa. (pausa) Esse é o mapa da concorrência, e ele tem dois eixos.</a:t>
             </a:r>
           </a:p>
           <a:p/>
@@ -1998,43 +1998,43 @@
           <a:lstStyle/>
           <a:p>
             <a:r>
-              <a:t>O ponto deste slide: Tirar o risco de fornecedor da mesa em vinte segundos. Trocar de LLM é variável de ambiente, não reescrita. E a decisão que vale repetir: a figura do card vem do acervo da Wikipédia, nunca de modelo de imagem — porque diagrama científico gerado por IA sai errado, e num app de educação erro se propaga pela fila de revisão.</a:t>
-            </a:r>
-          </a:p>
-          <a:p/>
-          <a:p>
-            <a:r>
-              <a:t>No slide: três cartões — modelo trocável, a figura vinda do acervo (destacado), e a stack.</a:t>
-            </a:r>
-          </a:p>
-          <a:p/>
-          <a:p>
-            <a:r>
-              <a:t>Fala: "Três coisas, rápido. (pausa)</a:t>
-            </a:r>
-          </a:p>
-          <a:p/>
-          <a:p>
-            <a:r>
-              <a:t>Um: trocar de modelo de IA aqui é mudar uma variável de ambiente. Duas implementações da mesma interface, e a saída passa por validação de schema antes de virar card. Hoje roda no tier gratuito do Gemini — o custo de inferência é substituível, não estrutural.</a:t>
-            </a:r>
-          </a:p>
-          <a:p/>
-          <a:p>
-            <a:r>
-              <a:t>Dois, e essa é a decisão que nos separa: a figura de cada card vem do acervo da Wikipédia. Nunca de modelo de imagem. Diagrama científico gerado por IA sai com a seta trocada e a molécula inventada. Num app de educação isso ensina errado — e o erro se propaga justamente pela fila de revisão, que é o que fixa memória.</a:t>
-            </a:r>
-          </a:p>
-          <a:p/>
-          <a:p>
-            <a:r>
-              <a:t>Três: a stack é aberta das duas pontas, com a mesma API servindo o aluno e o professor."</a:t>
-            </a:r>
-          </a:p>
-          <a:p/>
-          <a:p>
-            <a:r>
-              <a:t>O item dois é o que fica na cabeça do jurado — diga devagar. Deixa: "E como isso se sustenta?"</a:t>
+              <a:t>O ponto deste slide: Num hackathon a pergunta que o júri realmente faz é "vocês construíram mesmo?". Este slide responde antes de ser perguntado, e convida à verificação na hora: o QR abre no navegador do celular do jurado, sem instalar nada. Quem escaneia durante o pitch sai convencido de um jeito que nenhum slide convence.</a:t>
+            </a:r>
+          </a:p>
+          <a:p/>
+          <a:p>
+            <a:r>
+              <a:t>No slide: o painel do professor grande à esquerda, duas telas do app à direita, o QR embaixo e três fatos curtos.</a:t>
+            </a:r>
+          </a:p>
+          <a:p/>
+          <a:p>
+            <a:r>
+              <a:t>Fala: "E eu não vim mostrar maquete. (pausa)</a:t>
+            </a:r>
+          </a:p>
+          <a:p/>
+          <a:p>
+            <a:r>
+              <a:t>Isso aí é o painel rodando, com a turma de trinta e quatro alunos. Isso aqui é o app, com card gerado por IA. Os três estão no ar agora: app, painel e API.</a:t>
+            </a:r>
+          </a:p>
+          <a:p/>
+          <a:p>
+            <a:r>
+              <a:t>Se vocês quiserem conferir enquanto eu falo — aponta a câmera no QR. Abre no navegador do celular de vocês, sem loja, sem instalar, sem cadastro. Um botão entra como aluno, outro como professor. (pausa)</a:t>
+            </a:r>
+          </a:p>
+          <a:p/>
+          <a:p>
+            <a:r>
+              <a:t>E tem uma decisão ali que eu faço questão de dizer em voz alta: a figura de cada card vem do acervo da Wikipédia. Nunca de modelo de imagem. Diagrama científico gerado por IA sai com a seta trocada — e num app de educação isso ensina errado."</a:t>
+            </a:r>
+          </a:p>
+          <a:p/>
+          <a:p>
+            <a:r>
+              <a:t>Diga "aponta a câmera" olhando para a plateia, não para o slide — e pare de falar por dois segundos para as pessoas pegarem o celular. Se alguém escanear, você ganhou o pitch. Deixa: "E como isso se sustenta?"</a:t>
             </a:r>
           </a:p>
         </p:txBody>

</xml_diff>

<commit_message>
fix: make the dark band readable and stop stacking every slide at the top
The economics band renders dark on a light slide, so its text inherited the light-slide colour
and disappeared. The body of each slide now takes the free space instead of leaving it all
above the footer, and the revenue disclaimer moved to the script — it is an answer to hold,
not a line to project.
</commit_message>
<xml_diff>
--- a/docs/pitch/Memfeed-Pitch-Deck.pptx
+++ b/docs/pitch/Memfeed-Pitch-Deck.pptx
@@ -628,6 +628,12 @@
         <p:txBody>
           <a:bodyPr/>
           <a:lstStyle/>
+          <a:p>
+            <a:r>
+              <a:t>Se perguntarem de número: não há projeção de receita em nenhum slide, e é de propósito — não há tração, não há usuário real, não há depoimento; o produto nasceu esta semana e o pedido é um piloto, não um contrato. Os preços citados (Quizlet Plus US$ 2,99/mês; cursinho ENEM do Descomplica 12× R$ 49,90) são referência de mercado verificada em 13/09/2026, usada como âncora e nunca como nosso preço. O contexto de mercado vem de PISA 2022 (INEP/OCDE) e do Censo Escolar 2025 (Inep).</a:t>
+            </a:r>
+          </a:p>
+          <a:p/>
           <a:p>
             <a:r>
               <a:t>O ponto deste slide: Fechar mostrando que a conta fecha por causa da arquitetura, não apesar dela. A aula do professor é gerada uma vez e consumida por 34 alunos; a geração que o aluno pede é 1:1. Por isso a escola pública sai de graça sem quebrar o modelo. Termine no lema e segure o silêncio.</a:t>

</xml_diff>